<commit_message>
Update upload-health-check proposal with 13-14.09 fix-verification findings
Added §8 to the .md: real-world confirmation of §1's hypothesis (12.09 reconversion test, n=3/3), a calibration-risk data point (13.09 regression on question 6.2 within ЭКО_2), and a note on a separate, unfixed citation-card ranking bug found during fix-verification — explicitly out of this proposal's scope but relevant context. Added a matching slide 12/13 to the presentation (duplicated slide 7's 3-column layout via add_slide.py, edited text, adjusted footers, validated).

Co-Authored-By: Claude Sonnet 5 <noreply@anthropic.com>
Claude-Session: https://claude.ai/code/session_01DpSN8JwCJ3tg3JVUadr2zE
</commit_message>
<xml_diff>
--- a/docs/accounts/eco/proverka-zdorovya-zagruzki-presentation.pptx
+++ b/docs/accounts/eco/proverka-zdorovya-zagruzki-presentation.pptx
@@ -16,6 +16,7 @@
     <p:sldId id="264" r:id="rId10"/>
     <p:sldId id="265" r:id="rId11"/>
     <p:sldId id="266" r:id="rId12"/>
+    <p:sldId id="268" r:id="rId19"/>
     <p:sldId id="267" r:id="rId13"/>
   </p:sldIdLst>
   <p:notesMasterIdLst>
@@ -2336,7 +2337,7 @@
                 <a:ea typeface="Calibri" pitchFamily="34" charset="-122"/>
                 <a:cs typeface="Calibri" pitchFamily="34" charset="-120"/>
               </a:rPr>
-              <a:t>1 / 12</a:t>
+              <a:t>1 / 13</a:t>
             </a:r>
             <a:endParaRPr lang="en-US" sz="900" dirty="0"/>
           </a:p>
@@ -2821,7 +2822,7 @@
                 <a:ea typeface="Calibri" pitchFamily="34" charset="-122"/>
                 <a:cs typeface="Calibri" pitchFamily="34" charset="-120"/>
               </a:rPr>
-              <a:t>10 / 12</a:t>
+              <a:t>10 / 13</a:t>
             </a:r>
             <a:endParaRPr lang="en-US" sz="900" dirty="0"/>
           </a:p>
@@ -3375,7 +3376,7 @@
                 <a:ea typeface="Calibri" pitchFamily="34" charset="-122"/>
                 <a:cs typeface="Calibri" pitchFamily="34" charset="-120"/>
               </a:rPr>
-              <a:t>11 / 12</a:t>
+              <a:t>11 / 13</a:t>
             </a:r>
             <a:endParaRPr lang="en-US" sz="900" dirty="0"/>
           </a:p>
@@ -4136,7 +4137,764 @@
                 <a:ea typeface="Calibri" pitchFamily="34" charset="-122"/>
                 <a:cs typeface="Calibri" pitchFamily="34" charset="-120"/>
               </a:rPr>
-              <a:t>12 / 12</a:t>
+              <a:t>13 / 13</a:t>
+            </a:r>
+            <a:endParaRPr lang="en-US" sz="900" dirty="0"/>
+          </a:p>
+        </p:txBody>
+      </p:sp>
+    </p:spTree>
+  </p:cSld>
+  <p:clrMapOvr>
+    <a:masterClrMapping/>
+  </p:clrMapOvr>
+</p:sld>
+</file>
+
+<file path=ppt/slides/slide13.xml><?xml version="1.0" encoding="utf-8"?>
+<p:sld xmlns:a="http://schemas.openxmlformats.org/drawingml/2006/main" xmlns:r="http://schemas.openxmlformats.org/officeDocument/2006/relationships" xmlns:p="http://schemas.openxmlformats.org/presentationml/2006/main">
+  <p:cSld name="Slide 7">
+    <p:bg>
+      <p:bgPr>
+        <a:solidFill>
+          <a:srgbClr val="FFFFFF"/>
+        </a:solidFill>
+      </p:bgPr>
+    </p:bg>
+    <p:spTree>
+      <p:nvGrpSpPr>
+        <p:cNvPr id="1" name=""/>
+        <p:cNvGrpSpPr/>
+        <p:nvPr/>
+      </p:nvGrpSpPr>
+      <p:grpSpPr>
+        <a:xfrm>
+          <a:off x="0" y="0"/>
+          <a:ext cx="0" cy="0"/>
+          <a:chOff x="0" y="0"/>
+          <a:chExt cx="0" cy="0"/>
+        </a:xfrm>
+      </p:grpSpPr>
+      <p:sp>
+        <p:nvSpPr>
+          <p:cNvPr id="2" name="Text 0"/>
+          <p:cNvSpPr txBox="1"/>
+          <p:nvPr/>
+        </p:nvSpPr>
+        <p:spPr>
+          <a:xfrm>
+            <a:off x="502920" y="384048"/>
+            <a:ext cx="11185855" cy="256032"/>
+          </a:xfrm>
+          <a:prstGeom prst="rect">
+            <a:avLst/>
+          </a:prstGeom>
+          <a:noFill/>
+          <a:ln/>
+        </p:spPr>
+        <p:txBody>
+          <a:bodyPr wrap="square" lIns="0" tIns="0" rIns="0" bIns="0" rtlCol="0" anchor="ctr"/>
+          <a:lstStyle/>
+          <a:p>
+            <a:pPr indent="0" marL="0">
+              <a:buNone/>
+            </a:pPr>
+            <a:r>
+              <a:rPr lang="en-US" sz="1100" b="1" spc="120" kern="0" dirty="0">
+                <a:solidFill>
+                  <a:srgbClr val="0E7C86"/>
+                </a:solidFill>
+                <a:latin typeface="Calibri" pitchFamily="34" charset="0"/>
+                <a:ea typeface="Calibri" pitchFamily="34" charset="-122"/>
+                <a:cs typeface="Calibri" pitchFamily="34" charset="-120"/>
+              </a:rPr>
+              <a:t>ОБНОВЛЕНИЕ · 13–14.09.2026</a:t>
+            </a:r>
+            <a:endParaRPr lang="en-US" sz="1100" dirty="0"/>
+          </a:p>
+        </p:txBody>
+      </p:sp>
+      <p:sp>
+        <p:nvSpPr>
+          <p:cNvPr id="3" name="Text 1"/>
+          <p:cNvSpPr txBox="1"/>
+          <p:nvPr/>
+        </p:nvSpPr>
+        <p:spPr>
+          <a:xfrm>
+            <a:off x="502920" y="676656"/>
+            <a:ext cx="11185855" cy="438912"/>
+          </a:xfrm>
+          <a:prstGeom prst="rect">
+            <a:avLst/>
+          </a:prstGeom>
+          <a:noFill/>
+          <a:ln/>
+        </p:spPr>
+        <p:txBody>
+          <a:bodyPr wrap="square" lIns="0" tIns="0" rIns="0" bIns="0" rtlCol="0" anchor="t"/>
+          <a:lstStyle/>
+          <a:p>
+            <a:pPr indent="0" marL="0">
+              <a:buNone/>
+            </a:pPr>
+            <a:r>
+              <a:rPr lang="en-US" sz="2400" b="1" dirty="0">
+                <a:solidFill>
+                  <a:srgbClr val="1A2733"/>
+                </a:solidFill>
+                <a:latin typeface="Cambria" pitchFamily="34" charset="0"/>
+                <a:ea typeface="Cambria" pitchFamily="34" charset="-122"/>
+                <a:cs typeface="Cambria" pitchFamily="34" charset="-120"/>
+              </a:rPr>
+              <a:t>Что подтвердилось, что нашли нового</a:t>
+            </a:r>
+            <a:endParaRPr lang="en-US" sz="2400" dirty="0"/>
+          </a:p>
+        </p:txBody>
+      </p:sp>
+      <p:sp>
+        <p:nvSpPr>
+          <p:cNvPr id="4" name="Text 2"/>
+          <p:cNvSpPr txBox="1"/>
+          <p:nvPr/>
+        </p:nvSpPr>
+        <p:spPr>
+          <a:xfrm>
+            <a:off x="502920" y="1152144"/>
+            <a:ext cx="11185855" cy="329184"/>
+          </a:xfrm>
+          <a:prstGeom prst="rect">
+            <a:avLst/>
+          </a:prstGeom>
+          <a:noFill/>
+          <a:ln/>
+        </p:spPr>
+        <p:txBody>
+          <a:bodyPr wrap="square" lIns="0" tIns="0" rIns="0" bIns="0" rtlCol="0" anchor="t"/>
+          <a:lstStyle/>
+          <a:p>
+            <a:pPr indent="0" marL="0">
+              <a:buNone/>
+            </a:pPr>
+            <a:r>
+              <a:rPr lang="en-US" sz="1250" dirty="0">
+                <a:solidFill>
+                  <a:srgbClr val="5B6B7A"/>
+                </a:solidFill>
+                <a:latin typeface="Calibri" pitchFamily="34" charset="0"/>
+                <a:ea typeface="Calibri" pitchFamily="34" charset="-122"/>
+                <a:cs typeface="Calibri" pitchFamily="34" charset="-120"/>
+              </a:rPr>
+              <a:t>Живой ретест на пилоте «Эко Ресурс» — после заявленного вендором фикса</a:t>
+            </a:r>
+            <a:endParaRPr lang="en-US" sz="1250" dirty="0"/>
+          </a:p>
+        </p:txBody>
+      </p:sp>
+      <p:sp>
+        <p:nvSpPr>
+          <p:cNvPr id="5" name="Shape 3"/>
+          <p:cNvSpPr/>
+          <p:nvPr/>
+        </p:nvSpPr>
+        <p:spPr>
+          <a:xfrm>
+            <a:off x="502920" y="1737360"/>
+            <a:ext cx="3545738" cy="2880360"/>
+          </a:xfrm>
+          <a:prstGeom prst="roundRect">
+            <a:avLst>
+              <a:gd name="adj" fmla="val 2540"/>
+            </a:avLst>
+          </a:prstGeom>
+          <a:solidFill>
+            <a:srgbClr val="F6F8F9"/>
+          </a:solidFill>
+          <a:ln w="12700">
+            <a:solidFill>
+              <a:srgbClr val="E1E6EA"/>
+            </a:solidFill>
+            <a:prstDash val="solid"/>
+          </a:ln>
+        </p:spPr>
+      </p:sp>
+      <p:sp>
+        <p:nvSpPr>
+          <p:cNvPr id="6" name="Shape 4"/>
+          <p:cNvSpPr/>
+          <p:nvPr/>
+        </p:nvSpPr>
+        <p:spPr>
+          <a:xfrm>
+            <a:off x="758952" y="1993392"/>
+            <a:ext cx="502920" cy="502920"/>
+          </a:xfrm>
+          <a:prstGeom prst="ellipse">
+            <a:avLst/>
+          </a:prstGeom>
+          <a:solidFill>
+            <a:srgbClr val="0E7C86"/>
+          </a:solidFill>
+          <a:ln/>
+        </p:spPr>
+      </p:sp>
+      <p:sp>
+        <p:nvSpPr>
+          <p:cNvPr id="7" name="Text 5"/>
+          <p:cNvSpPr txBox="1"/>
+          <p:nvPr/>
+        </p:nvSpPr>
+        <p:spPr>
+          <a:xfrm>
+            <a:off x="758952" y="1984248"/>
+            <a:ext cx="502920" cy="502920"/>
+          </a:xfrm>
+          <a:prstGeom prst="rect">
+            <a:avLst/>
+          </a:prstGeom>
+          <a:noFill/>
+          <a:ln/>
+        </p:spPr>
+        <p:txBody>
+          <a:bodyPr wrap="square" lIns="0" tIns="0" rIns="0" bIns="0" rtlCol="0" anchor="ctr"/>
+          <a:lstStyle/>
+          <a:p>
+            <a:pPr algn="ctr" indent="0" marL="0">
+              <a:buNone/>
+            </a:pPr>
+            <a:r>
+              <a:rPr lang="en-US" sz="2000" b="1" dirty="0">
+                <a:solidFill>
+                  <a:srgbClr val="FFFFFF"/>
+                </a:solidFill>
+                <a:latin typeface="Cambria" pitchFamily="34" charset="0"/>
+                <a:ea typeface="Cambria" pitchFamily="34" charset="-122"/>
+                <a:cs typeface="Cambria" pitchFamily="34" charset="-120"/>
+              </a:rPr>
+              <a:t>1</a:t>
+            </a:r>
+            <a:endParaRPr lang="en-US" sz="2000" dirty="0"/>
+          </a:p>
+        </p:txBody>
+      </p:sp>
+      <p:sp>
+        <p:nvSpPr>
+          <p:cNvPr id="8" name="Text 6"/>
+          <p:cNvSpPr txBox="1"/>
+          <p:nvPr/>
+        </p:nvSpPr>
+        <p:spPr>
+          <a:xfrm>
+            <a:off x="758952" y="2697480"/>
+            <a:ext cx="3033674" cy="777240"/>
+          </a:xfrm>
+          <a:prstGeom prst="rect">
+            <a:avLst/>
+          </a:prstGeom>
+          <a:noFill/>
+          <a:ln/>
+        </p:spPr>
+        <p:txBody>
+          <a:bodyPr wrap="square" lIns="0" tIns="0" rIns="0" bIns="0" rtlCol="0" anchor="ctr"/>
+          <a:lstStyle/>
+          <a:p>
+            <a:pPr indent="0" marL="0">
+              <a:lnSpc>
+                <a:spcPct val="110000"/>
+              </a:lnSpc>
+              <a:buNone/>
+            </a:pPr>
+            <a:r>
+              <a:rPr lang="en-US" sz="1650" b="1" dirty="0">
+                <a:solidFill>
+                  <a:srgbClr val="1A2733"/>
+                </a:solidFill>
+                <a:latin typeface="Cambria" pitchFamily="34" charset="0"/>
+                <a:ea typeface="Cambria" pitchFamily="34" charset="-122"/>
+                <a:cs typeface="Cambria" pitchFamily="34" charset="-120"/>
+              </a:rPr>
+              <a:t>Гипотеза подтвердилась</a:t>
+            </a:r>
+            <a:endParaRPr lang="en-US" sz="1650" dirty="0"/>
+          </a:p>
+        </p:txBody>
+      </p:sp>
+      <p:sp>
+        <p:nvSpPr>
+          <p:cNvPr id="9" name="Text 7"/>
+          <p:cNvSpPr txBox="1"/>
+          <p:nvPr/>
+        </p:nvSpPr>
+        <p:spPr>
+          <a:xfrm>
+            <a:off x="758952" y="3600000"/>
+            <a:ext cx="3033674" cy="926280"/>
+          </a:xfrm>
+          <a:prstGeom prst="rect">
+            <a:avLst/>
+          </a:prstGeom>
+          <a:noFill/>
+          <a:ln/>
+        </p:spPr>
+        <p:txBody>
+          <a:bodyPr wrap="square" lIns="0" tIns="0" rIns="0" bIns="0" rtlCol="0" anchor="ctr"/>
+          <a:lstStyle/>
+          <a:p>
+            <a:pPr indent="0" marL="0">
+              <a:lnSpc>
+                <a:spcPct val="125000"/>
+              </a:lnSpc>
+              <a:buNone/>
+            </a:pPr>
+            <a:r>
+              <a:rPr lang="en-US" sz="1200" dirty="0">
+                <a:solidFill>
+                  <a:srgbClr val="5B6B7A"/>
+                </a:solidFill>
+                <a:latin typeface="Calibri" pitchFamily="34" charset="0"/>
+                <a:ea typeface="Calibri" pitchFamily="34" charset="-122"/>
+                <a:cs typeface="Calibri" pitchFamily="34" charset="-120"/>
+              </a:rPr>
+              <a:t>12.09: переконвертация дала n=3/3 верных ответа (вопросы 5.2, 6.2, 2.2) там, где исходная загрузка стабильно проваливалась три раунда подряд — первое реальное подтверждение эффекта, не только расчёт по §1.</a:t>
+            </a:r>
+            <a:endParaRPr lang="en-US" sz="1200" dirty="0"/>
+          </a:p>
+        </p:txBody>
+      </p:sp>
+      <p:sp>
+        <p:nvSpPr>
+          <p:cNvPr id="10" name="Shape 8"/>
+          <p:cNvSpPr/>
+          <p:nvPr/>
+        </p:nvSpPr>
+        <p:spPr>
+          <a:xfrm>
+            <a:off x="4322978" y="1737360"/>
+            <a:ext cx="3545738" cy="2880360"/>
+          </a:xfrm>
+          <a:prstGeom prst="roundRect">
+            <a:avLst>
+              <a:gd name="adj" fmla="val 2540"/>
+            </a:avLst>
+          </a:prstGeom>
+          <a:solidFill>
+            <a:srgbClr val="F6F8F9"/>
+          </a:solidFill>
+          <a:ln w="12700">
+            <a:solidFill>
+              <a:srgbClr val="E1E6EA"/>
+            </a:solidFill>
+            <a:prstDash val="solid"/>
+          </a:ln>
+        </p:spPr>
+      </p:sp>
+      <p:sp>
+        <p:nvSpPr>
+          <p:cNvPr id="11" name="Shape 9"/>
+          <p:cNvSpPr/>
+          <p:nvPr/>
+        </p:nvSpPr>
+        <p:spPr>
+          <a:xfrm>
+            <a:off x="4579010" y="1993392"/>
+            <a:ext cx="502920" cy="502920"/>
+          </a:xfrm>
+          <a:prstGeom prst="ellipse">
+            <a:avLst/>
+          </a:prstGeom>
+          <a:solidFill>
+            <a:srgbClr val="0E7C86"/>
+          </a:solidFill>
+          <a:ln/>
+        </p:spPr>
+      </p:sp>
+      <p:sp>
+        <p:nvSpPr>
+          <p:cNvPr id="12" name="Text 10"/>
+          <p:cNvSpPr txBox="1"/>
+          <p:nvPr/>
+        </p:nvSpPr>
+        <p:spPr>
+          <a:xfrm>
+            <a:off x="4579010" y="1984248"/>
+            <a:ext cx="502920" cy="502920"/>
+          </a:xfrm>
+          <a:prstGeom prst="rect">
+            <a:avLst/>
+          </a:prstGeom>
+          <a:noFill/>
+          <a:ln/>
+        </p:spPr>
+        <p:txBody>
+          <a:bodyPr wrap="square" lIns="0" tIns="0" rIns="0" bIns="0" rtlCol="0" anchor="ctr"/>
+          <a:lstStyle/>
+          <a:p>
+            <a:pPr algn="ctr" indent="0" marL="0">
+              <a:buNone/>
+            </a:pPr>
+            <a:r>
+              <a:rPr lang="en-US" sz="2000" b="1" dirty="0">
+                <a:solidFill>
+                  <a:srgbClr val="FFFFFF"/>
+                </a:solidFill>
+                <a:latin typeface="Cambria" pitchFamily="34" charset="0"/>
+                <a:ea typeface="Cambria" pitchFamily="34" charset="-122"/>
+                <a:cs typeface="Cambria" pitchFamily="34" charset="-120"/>
+              </a:rPr>
+              <a:t>2</a:t>
+            </a:r>
+            <a:endParaRPr lang="en-US" sz="2000" dirty="0"/>
+          </a:p>
+        </p:txBody>
+      </p:sp>
+      <p:sp>
+        <p:nvSpPr>
+          <p:cNvPr id="13" name="Text 11"/>
+          <p:cNvSpPr txBox="1"/>
+          <p:nvPr/>
+        </p:nvSpPr>
+        <p:spPr>
+          <a:xfrm>
+            <a:off x="4579010" y="2697480"/>
+            <a:ext cx="3033674" cy="777240"/>
+          </a:xfrm>
+          <a:prstGeom prst="rect">
+            <a:avLst/>
+          </a:prstGeom>
+          <a:noFill/>
+          <a:ln/>
+        </p:spPr>
+        <p:txBody>
+          <a:bodyPr wrap="square" lIns="0" tIns="0" rIns="0" bIns="0" rtlCol="0" anchor="ctr"/>
+          <a:lstStyle/>
+          <a:p>
+            <a:pPr indent="0" marL="0">
+              <a:lnSpc>
+                <a:spcPct val="110000"/>
+              </a:lnSpc>
+              <a:buNone/>
+            </a:pPr>
+            <a:r>
+              <a:rPr lang="en-US" sz="1650" b="1" dirty="0">
+                <a:solidFill>
+                  <a:srgbClr val="1A2733"/>
+                </a:solidFill>
+                <a:latin typeface="Cambria" pitchFamily="34" charset="0"/>
+                <a:ea typeface="Cambria" pitchFamily="34" charset="-122"/>
+                <a:cs typeface="Cambria" pitchFamily="34" charset="-120"/>
+              </a:rPr>
+              <a:t>Риск калибровки сбылся</a:t>
+            </a:r>
+            <a:endParaRPr lang="en-US" sz="1650" dirty="0"/>
+          </a:p>
+        </p:txBody>
+      </p:sp>
+      <p:sp>
+        <p:nvSpPr>
+          <p:cNvPr id="14" name="Text 12"/>
+          <p:cNvSpPr txBox="1"/>
+          <p:nvPr/>
+        </p:nvSpPr>
+        <p:spPr>
+          <a:xfrm>
+            <a:off x="4579010" y="3600000"/>
+            <a:ext cx="3033674" cy="926280"/>
+          </a:xfrm>
+          <a:prstGeom prst="rect">
+            <a:avLst/>
+          </a:prstGeom>
+          <a:noFill/>
+          <a:ln/>
+        </p:spPr>
+        <p:txBody>
+          <a:bodyPr wrap="square" lIns="0" tIns="0" rIns="0" bIns="0" rtlCol="0" anchor="ctr"/>
+          <a:lstStyle/>
+          <a:p>
+            <a:pPr indent="0" marL="0">
+              <a:lnSpc>
+                <a:spcPct val="125000"/>
+              </a:lnSpc>
+              <a:buNone/>
+            </a:pPr>
+            <a:r>
+              <a:rPr lang="en-US" sz="1200" dirty="0">
+                <a:solidFill>
+                  <a:srgbClr val="5B6B7A"/>
+                </a:solidFill>
+                <a:latin typeface="Calibri" pitchFamily="34" charset="0"/>
+                <a:ea typeface="Calibri" pitchFamily="34" charset="-122"/>
+                <a:cs typeface="Calibri" pitchFamily="34" charset="-120"/>
+              </a:rPr>
+              <a:t>13.09: повторная проверка того же документа (6.2) на той же ЭКО_2 неожиданно его не нашла. Один прогон — не статистика, но подтверждает предупреждение §7: нужен постоянный мониторинг, не разовый тест.</a:t>
+            </a:r>
+            <a:endParaRPr lang="en-US" sz="1200" dirty="0"/>
+          </a:p>
+        </p:txBody>
+      </p:sp>
+      <p:sp>
+        <p:nvSpPr>
+          <p:cNvPr id="15" name="Shape 13"/>
+          <p:cNvSpPr/>
+          <p:nvPr/>
+        </p:nvSpPr>
+        <p:spPr>
+          <a:xfrm>
+            <a:off x="8143037" y="1737360"/>
+            <a:ext cx="3545738" cy="2880360"/>
+          </a:xfrm>
+          <a:prstGeom prst="roundRect">
+            <a:avLst>
+              <a:gd name="adj" fmla="val 2540"/>
+            </a:avLst>
+          </a:prstGeom>
+          <a:solidFill>
+            <a:srgbClr val="F6F8F9"/>
+          </a:solidFill>
+          <a:ln w="12700">
+            <a:solidFill>
+              <a:srgbClr val="E1E6EA"/>
+            </a:solidFill>
+            <a:prstDash val="solid"/>
+          </a:ln>
+        </p:spPr>
+      </p:sp>
+      <p:sp>
+        <p:nvSpPr>
+          <p:cNvPr id="16" name="Shape 14"/>
+          <p:cNvSpPr/>
+          <p:nvPr/>
+        </p:nvSpPr>
+        <p:spPr>
+          <a:xfrm>
+            <a:off x="8399069" y="1993392"/>
+            <a:ext cx="502920" cy="502920"/>
+          </a:xfrm>
+          <a:prstGeom prst="ellipse">
+            <a:avLst/>
+          </a:prstGeom>
+          <a:solidFill>
+            <a:srgbClr val="C98A2E"/>
+          </a:solidFill>
+          <a:ln/>
+        </p:spPr>
+      </p:sp>
+      <p:sp>
+        <p:nvSpPr>
+          <p:cNvPr id="17" name="Text 15"/>
+          <p:cNvSpPr txBox="1"/>
+          <p:nvPr/>
+        </p:nvSpPr>
+        <p:spPr>
+          <a:xfrm>
+            <a:off x="8399069" y="1984248"/>
+            <a:ext cx="502920" cy="502920"/>
+          </a:xfrm>
+          <a:prstGeom prst="rect">
+            <a:avLst/>
+          </a:prstGeom>
+          <a:noFill/>
+          <a:ln/>
+        </p:spPr>
+        <p:txBody>
+          <a:bodyPr wrap="square" lIns="0" tIns="0" rIns="0" bIns="0" rtlCol="0" anchor="ctr"/>
+          <a:lstStyle/>
+          <a:p>
+            <a:pPr algn="ctr" indent="0" marL="0">
+              <a:buNone/>
+            </a:pPr>
+            <a:r>
+              <a:rPr lang="en-US" sz="2000" b="1" dirty="0">
+                <a:solidFill>
+                  <a:srgbClr val="FFFFFF"/>
+                </a:solidFill>
+                <a:latin typeface="Cambria" pitchFamily="34" charset="0"/>
+                <a:ea typeface="Cambria" pitchFamily="34" charset="-122"/>
+                <a:cs typeface="Cambria" pitchFamily="34" charset="-120"/>
+              </a:rPr>
+              <a:t>3</a:t>
+            </a:r>
+            <a:endParaRPr lang="en-US" sz="2000" dirty="0"/>
+          </a:p>
+        </p:txBody>
+      </p:sp>
+      <p:sp>
+        <p:nvSpPr>
+          <p:cNvPr id="18" name="Text 16"/>
+          <p:cNvSpPr txBox="1"/>
+          <p:nvPr/>
+        </p:nvSpPr>
+        <p:spPr>
+          <a:xfrm>
+            <a:off x="8399069" y="2697480"/>
+            <a:ext cx="3033674" cy="777240"/>
+          </a:xfrm>
+          <a:prstGeom prst="rect">
+            <a:avLst/>
+          </a:prstGeom>
+          <a:noFill/>
+          <a:ln/>
+        </p:spPr>
+        <p:txBody>
+          <a:bodyPr wrap="square" lIns="0" tIns="0" rIns="0" bIns="0" rtlCol="0" anchor="ctr"/>
+          <a:lstStyle/>
+          <a:p>
+            <a:pPr indent="0" marL="0">
+              <a:lnSpc>
+                <a:spcPct val="110000"/>
+              </a:lnSpc>
+              <a:buNone/>
+            </a:pPr>
+            <a:r>
+              <a:rPr lang="en-US" sz="1650" b="1" dirty="0">
+                <a:solidFill>
+                  <a:srgbClr val="1A2733"/>
+                </a:solidFill>
+                <a:latin typeface="Cambria" pitchFamily="34" charset="0"/>
+                <a:ea typeface="Cambria" pitchFamily="34" charset="-122"/>
+                <a:cs typeface="Cambria" pitchFamily="34" charset="-120"/>
+              </a:rPr>
+              <a:t>Найден отдельный баг</a:t>
+            </a:r>
+            <a:endParaRPr lang="en-US" sz="1650" dirty="0"/>
+          </a:p>
+        </p:txBody>
+      </p:sp>
+      <p:sp>
+        <p:nvSpPr>
+          <p:cNvPr id="19" name="Text 17"/>
+          <p:cNvSpPr txBox="1"/>
+          <p:nvPr/>
+        </p:nvSpPr>
+        <p:spPr>
+          <a:xfrm>
+            <a:off x="8399069" y="3600000"/>
+            <a:ext cx="3033674" cy="926280"/>
+          </a:xfrm>
+          <a:prstGeom prst="rect">
+            <a:avLst/>
+          </a:prstGeom>
+          <a:noFill/>
+          <a:ln/>
+        </p:spPr>
+        <p:txBody>
+          <a:bodyPr wrap="square" lIns="0" tIns="0" rIns="0" bIns="0" rtlCol="0" anchor="ctr"/>
+          <a:lstStyle/>
+          <a:p>
+            <a:pPr indent="0" marL="0">
+              <a:lnSpc>
+                <a:spcPct val="125000"/>
+              </a:lnSpc>
+              <a:buNone/>
+            </a:pPr>
+            <a:r>
+              <a:rPr lang="en-US" sz="1200" dirty="0">
+                <a:solidFill>
+                  <a:srgbClr val="5B6B7A"/>
+                </a:solidFill>
+                <a:latin typeface="Calibri" pitchFamily="34" charset="0"/>
+                <a:ea typeface="Calibri" pitchFamily="34" charset="-122"/>
+                <a:cs typeface="Calibri" pitchFamily="34" charset="-120"/>
+              </a:rPr>
+              <a:t>Карточка источника систематически не совпадает с текстом ответа (26 тестов, 13.09, протокол pilot-test-04) — подтверждено, НЕ исправлено вендором, шире исходного масштаба.</a:t>
+            </a:r>
+            <a:endParaRPr lang="en-US" sz="1200" dirty="0"/>
+          </a:p>
+        </p:txBody>
+      </p:sp>
+      <p:sp>
+        <p:nvSpPr>
+          <p:cNvPr id="20" name="Text 18"/>
+          <p:cNvSpPr txBox="1"/>
+          <p:nvPr/>
+        </p:nvSpPr>
+        <p:spPr>
+          <a:xfrm>
+            <a:off x="502920" y="4892040"/>
+            <a:ext cx="11185855" cy="685800"/>
+          </a:xfrm>
+          <a:prstGeom prst="rect">
+            <a:avLst/>
+          </a:prstGeom>
+          <a:noFill/>
+          <a:ln/>
+        </p:spPr>
+        <p:txBody>
+          <a:bodyPr wrap="square" lIns="0" tIns="0" rIns="0" bIns="0" rtlCol="0" anchor="ctr"/>
+          <a:lstStyle/>
+          <a:p>
+            <a:pPr indent="0" marL="0">
+              <a:lnSpc>
+                <a:spcPct val="130000"/>
+              </a:lnSpc>
+              <a:buNone/>
+            </a:pPr>
+            <a:r>
+              <a:rPr lang="en-US" sz="1250" b="1" dirty="0">
+                <a:solidFill>
+                  <a:srgbClr val="1A2733"/>
+                </a:solidFill>
+                <a:latin typeface="Calibri" pitchFamily="34" charset="0"/>
+                <a:ea typeface="Calibri" pitchFamily="34" charset="-122"/>
+                <a:cs typeface="Calibri" pitchFamily="34" charset="-120"/>
+              </a:rPr>
+              <a:t>Это не ошибка ингестии — документ уже есть в индексе. </a:t>
+            </a:r>
+            <a:pPr indent="0" marL="0">
+              <a:lnSpc>
+                <a:spcPct val="130000"/>
+              </a:lnSpc>
+              <a:buNone/>
+            </a:pPr>
+            <a:r>
+              <a:rPr lang="en-US" sz="1250" dirty="0">
+                <a:solidFill>
+                  <a:srgbClr val="5B6B7A"/>
+                </a:solidFill>
+                <a:latin typeface="Calibri" pitchFamily="34" charset="0"/>
+                <a:ea typeface="Calibri" pitchFamily="34" charset="-122"/>
+                <a:cs typeface="Calibri" pitchFamily="34" charset="-120"/>
+              </a:rPr>
+              <a:t>Проверка §2 этот класс дефектов не поймает (см. §2 «чего это не ловит») — упомянуто как честное дополнение к карте проблем платформы, не как довод за эту фичу.</a:t>
+            </a:r>
+            <a:endParaRPr lang="en-US" sz="1250" dirty="0"/>
+          </a:p>
+        </p:txBody>
+      </p:sp>
+      <p:sp>
+        <p:nvSpPr>
+          <p:cNvPr id="21" name="Text 19"/>
+          <p:cNvSpPr txBox="1"/>
+          <p:nvPr/>
+        </p:nvSpPr>
+        <p:spPr>
+          <a:xfrm>
+            <a:off x="11002975" y="6473952"/>
+            <a:ext cx="822960" cy="274320"/>
+          </a:xfrm>
+          <a:prstGeom prst="rect">
+            <a:avLst/>
+          </a:prstGeom>
+          <a:noFill/>
+          <a:ln/>
+        </p:spPr>
+        <p:txBody>
+          <a:bodyPr wrap="square" lIns="0" tIns="0" rIns="0" bIns="0" rtlCol="0" anchor="ctr"/>
+          <a:lstStyle/>
+          <a:p>
+            <a:pPr algn="r" indent="0" marL="0">
+              <a:buNone/>
+            </a:pPr>
+            <a:r>
+              <a:rPr lang="en-US" sz="900" dirty="0">
+                <a:solidFill>
+                  <a:srgbClr val="8695A3"/>
+                </a:solidFill>
+                <a:latin typeface="Calibri" pitchFamily="34" charset="0"/>
+                <a:ea typeface="Calibri" pitchFamily="34" charset="-122"/>
+                <a:cs typeface="Calibri" pitchFamily="34" charset="-120"/>
+              </a:rPr>
+              <a:t>12 / 13</a:t>
             </a:r>
             <a:endParaRPr lang="en-US" sz="900" dirty="0"/>
           </a:p>
@@ -4681,7 +5439,7 @@
                 <a:ea typeface="Calibri" pitchFamily="34" charset="-122"/>
                 <a:cs typeface="Calibri" pitchFamily="34" charset="-120"/>
               </a:rPr>
-              <a:t>2 / 12</a:t>
+              <a:t>2 / 13</a:t>
             </a:r>
             <a:endParaRPr lang="en-US" sz="900" dirty="0"/>
           </a:p>
@@ -6735,7 +7493,7 @@
                 <a:ea typeface="Calibri" pitchFamily="34" charset="-122"/>
                 <a:cs typeface="Calibri" pitchFamily="34" charset="-120"/>
               </a:rPr>
-              <a:t>3 / 12</a:t>
+              <a:t>3 / 13</a:t>
             </a:r>
             <a:endParaRPr lang="en-US" sz="900" dirty="0"/>
           </a:p>
@@ -7492,7 +8250,7 @@
                 <a:ea typeface="Calibri" pitchFamily="34" charset="-122"/>
                 <a:cs typeface="Calibri" pitchFamily="34" charset="-120"/>
               </a:rPr>
-              <a:t>4 / 12</a:t>
+              <a:t>4 / 13</a:t>
             </a:r>
             <a:endParaRPr lang="en-US" sz="900" dirty="0"/>
           </a:p>
@@ -8342,7 +9100,7 @@
                 <a:ea typeface="Calibri" pitchFamily="34" charset="-122"/>
                 <a:cs typeface="Calibri" pitchFamily="34" charset="-120"/>
               </a:rPr>
-              <a:t>5 / 12</a:t>
+              <a:t>5 / 13</a:t>
             </a:r>
             <a:endParaRPr lang="en-US" sz="900" dirty="0"/>
           </a:p>
@@ -10209,7 +10967,7 @@
                 <a:ea typeface="Calibri" pitchFamily="34" charset="-122"/>
                 <a:cs typeface="Calibri" pitchFamily="34" charset="-120"/>
               </a:rPr>
-              <a:t>6 / 12</a:t>
+              <a:t>6 / 13</a:t>
             </a:r>
             <a:endParaRPr lang="en-US" sz="900" dirty="0"/>
           </a:p>
@@ -10966,7 +11724,7 @@
                 <a:ea typeface="Calibri" pitchFamily="34" charset="-122"/>
                 <a:cs typeface="Calibri" pitchFamily="34" charset="-120"/>
               </a:rPr>
-              <a:t>7 / 12</a:t>
+              <a:t>7 / 13</a:t>
             </a:r>
             <a:endParaRPr lang="en-US" sz="900" dirty="0"/>
           </a:p>
@@ -11762,7 +12520,7 @@
                 <a:ea typeface="Calibri" pitchFamily="34" charset="-122"/>
                 <a:cs typeface="Calibri" pitchFamily="34" charset="-120"/>
               </a:rPr>
-              <a:t>8 / 12</a:t>
+              <a:t>8 / 13</a:t>
             </a:r>
             <a:endParaRPr lang="en-US" sz="900" dirty="0"/>
           </a:p>
@@ -12523,7 +13281,7 @@
                 <a:ea typeface="Calibri" pitchFamily="34" charset="-122"/>
                 <a:cs typeface="Calibri" pitchFamily="34" charset="-120"/>
               </a:rPr>
-              <a:t>9 / 12</a:t>
+              <a:t>9 / 13</a:t>
             </a:r>
             <a:endParaRPr lang="en-US" sz="900" dirty="0"/>
           </a:p>

</xml_diff>